<commit_message>
Rebuild the showcases with Vixl 0.27.0
Run every exploration, the logo alternatives, the marketing pack, both promo
films, the variety pack and The Germ King again, recompose the explorations
gallery, and re-render the Heyoka collection and Rain girl from their sources
(art/rerender.py).

Changes needed for 0.27: 02 snaps the business-card guides (now on half
pixels) and moves the brand board header and footer onto its safe line; 07
reads design issues in production checks, asks the CSV job for the review
profile and moves the footer inside the safe margin; 09 locks the previewed
layout before roll --apply, sizes the YouTube banner button, and saves its
workspace documents with overwrite; marketing prefixes imported logo layer
names; the promo scenes read the documentation images from the Vixl
repository; Rain girl leaves the street out of the watercolor look.
</commit_message>
<xml_diff>
--- a/marketing/output/deck/vixl-pitch-deck.pptx
+++ b/marketing/output/deck/vixl-pitch-deck.pptx
@@ -219,7 +219,7 @@
         <c:axId val="222222222"/>
         <c:scaling>
           <c:orientation val="minMax"/>
-          <c:max val="8"/>
+          <c:max val="10"/>
           <c:min val="0"/>
         </c:scaling>
         <c:delete val="0"/>
@@ -263,7 +263,7 @@
         <c:crossAx val="111111111"/>
         <c:crosses val="autoZero"/>
         <c:crossBetween val="between"/>
-        <c:majorUnit val="2"/>
+        <c:majorUnit val="5"/>
       </c:valAx>
       <c:spPr>
         <a:noFill/>
@@ -1303,7 +1303,7 @@
         </p:grpSpPr>
         <p:sp>
           <p:nvSpPr>
-            <p:cNvPr id="2" name="footer-logo-1"/>
+            <p:cNvPr id="2" name="footer-logo-v"/>
             <p:cNvSpPr/>
             <p:nvPr/>
           </p:nvSpPr>
@@ -1358,7 +1358,7 @@
         </p:sp>
         <p:sp>
           <p:nvSpPr>
-            <p:cNvPr id="3" name="footer-logo-2"/>
+            <p:cNvPr id="3" name="footer-logo-i stem"/>
             <p:cNvSpPr/>
             <p:nvPr/>
           </p:nvSpPr>
@@ -1404,7 +1404,7 @@
         </p:sp>
         <p:sp>
           <p:nvSpPr>
-            <p:cNvPr id="4" name="footer-logo-3"/>
+            <p:cNvPr id="4" name="footer-logo-i dot"/>
             <p:cNvSpPr/>
             <p:nvPr/>
           </p:nvSpPr>
@@ -1450,7 +1450,7 @@
         </p:sp>
         <p:sp>
           <p:nvSpPr>
-            <p:cNvPr id="5" name="footer-logo-4"/>
+            <p:cNvPr id="5" name="footer-logo-x"/>
             <p:cNvSpPr/>
             <p:nvPr/>
           </p:nvSpPr>
@@ -1505,7 +1505,7 @@
         </p:sp>
         <p:sp>
           <p:nvSpPr>
-            <p:cNvPr id="6" name="footer-logo-5"/>
+            <p:cNvPr id="6" name="footer-logo-x reflection band 1"/>
             <p:cNvSpPr/>
             <p:nvPr/>
           </p:nvSpPr>
@@ -1551,7 +1551,7 @@
         </p:sp>
         <p:sp>
           <p:nvSpPr>
-            <p:cNvPr id="7" name="footer-logo-6"/>
+            <p:cNvPr id="7" name="footer-logo-x reflection band 2"/>
             <p:cNvSpPr/>
             <p:nvPr/>
           </p:nvSpPr>
@@ -1597,7 +1597,7 @@
         </p:sp>
         <p:sp>
           <p:nvSpPr>
-            <p:cNvPr id="8" name="footer-logo-7"/>
+            <p:cNvPr id="8" name="footer-logo-x reflection band 3"/>
             <p:cNvSpPr/>
             <p:nvPr/>
           </p:nvSpPr>
@@ -1643,7 +1643,7 @@
         </p:sp>
         <p:sp>
           <p:nvSpPr>
-            <p:cNvPr id="9" name="footer-logo-8"/>
+            <p:cNvPr id="9" name="footer-logo-x reflection band 4"/>
             <p:cNvSpPr/>
             <p:nvPr/>
           </p:nvSpPr>
@@ -1698,7 +1698,7 @@
         </p:sp>
         <p:sp>
           <p:nvSpPr>
-            <p:cNvPr id="10" name="footer-logo-9"/>
+            <p:cNvPr id="10" name="footer-logo-x reflection band 5"/>
             <p:cNvSpPr/>
             <p:nvPr/>
           </p:nvSpPr>
@@ -1756,7 +1756,7 @@
         </p:sp>
         <p:sp>
           <p:nvSpPr>
-            <p:cNvPr id="11" name="footer-logo-10"/>
+            <p:cNvPr id="11" name="footer-logo-x reflection band 6"/>
             <p:cNvSpPr/>
             <p:nvPr/>
           </p:nvSpPr>
@@ -1814,7 +1814,7 @@
         </p:sp>
         <p:sp>
           <p:nvSpPr>
-            <p:cNvPr id="12" name="footer-logo-11"/>
+            <p:cNvPr id="12" name="footer-logo-x reflection band 7"/>
             <p:cNvSpPr/>
             <p:nvPr/>
           </p:nvSpPr>
@@ -1872,7 +1872,7 @@
         </p:sp>
         <p:sp>
           <p:nvSpPr>
-            <p:cNvPr id="13" name="footer-logo-12"/>
+            <p:cNvPr id="13" name="footer-logo-l"/>
             <p:cNvSpPr/>
             <p:nvPr/>
           </p:nvSpPr>
@@ -1918,7 +1918,7 @@
         </p:sp>
         <p:sp>
           <p:nvSpPr>
-            <p:cNvPr id="14" name="footer-logo-13"/>
+            <p:cNvPr id="14" name="footer-logo-l reflection band 1"/>
             <p:cNvSpPr/>
             <p:nvPr/>
           </p:nvSpPr>
@@ -1964,7 +1964,7 @@
         </p:sp>
         <p:sp>
           <p:nvSpPr>
-            <p:cNvPr id="15" name="footer-logo-14"/>
+            <p:cNvPr id="15" name="footer-logo-l reflection band 2"/>
             <p:cNvSpPr/>
             <p:nvPr/>
           </p:nvSpPr>
@@ -2010,7 +2010,7 @@
         </p:sp>
         <p:sp>
           <p:nvSpPr>
-            <p:cNvPr id="16" name="footer-logo-15"/>
+            <p:cNvPr id="16" name="footer-logo-l reflection band 3"/>
             <p:cNvSpPr/>
             <p:nvPr/>
           </p:nvSpPr>
@@ -2056,7 +2056,7 @@
         </p:sp>
         <p:sp>
           <p:nvSpPr>
-            <p:cNvPr id="17" name="footer-logo-16"/>
+            <p:cNvPr id="17" name="footer-logo-l reflection band 4"/>
             <p:cNvSpPr/>
             <p:nvPr/>
           </p:nvSpPr>
@@ -2102,7 +2102,7 @@
         </p:sp>
         <p:sp>
           <p:nvSpPr>
-            <p:cNvPr id="18" name="footer-logo-17"/>
+            <p:cNvPr id="18" name="footer-logo-l reflection band 5"/>
             <p:cNvSpPr/>
             <p:nvPr/>
           </p:nvSpPr>
@@ -2148,7 +2148,7 @@
         </p:sp>
         <p:sp>
           <p:nvSpPr>
-            <p:cNvPr id="19" name="footer-logo-18"/>
+            <p:cNvPr id="19" name="footer-logo-l reflection band 6"/>
             <p:cNvSpPr/>
             <p:nvPr/>
           </p:nvSpPr>
@@ -2194,7 +2194,7 @@
         </p:sp>
         <p:sp>
           <p:nvSpPr>
-            <p:cNvPr id="20" name="footer-logo-19"/>
+            <p:cNvPr id="20" name="footer-logo-l reflection band 7"/>
             <p:cNvSpPr/>
             <p:nvPr/>
           </p:nvSpPr>
@@ -3011,7 +3011,7 @@
         </p:grpSpPr>
         <p:sp>
           <p:nvSpPr>
-            <p:cNvPr id="2" name="footer-logo-1"/>
+            <p:cNvPr id="2" name="footer-logo-v"/>
             <p:cNvSpPr/>
             <p:nvPr/>
           </p:nvSpPr>
@@ -3066,7 +3066,7 @@
         </p:sp>
         <p:sp>
           <p:nvSpPr>
-            <p:cNvPr id="3" name="footer-logo-2"/>
+            <p:cNvPr id="3" name="footer-logo-i stem"/>
             <p:cNvSpPr/>
             <p:nvPr/>
           </p:nvSpPr>
@@ -3112,7 +3112,7 @@
         </p:sp>
         <p:sp>
           <p:nvSpPr>
-            <p:cNvPr id="4" name="footer-logo-3"/>
+            <p:cNvPr id="4" name="footer-logo-i dot"/>
             <p:cNvSpPr/>
             <p:nvPr/>
           </p:nvSpPr>
@@ -3158,7 +3158,7 @@
         </p:sp>
         <p:sp>
           <p:nvSpPr>
-            <p:cNvPr id="5" name="footer-logo-4"/>
+            <p:cNvPr id="5" name="footer-logo-x"/>
             <p:cNvSpPr/>
             <p:nvPr/>
           </p:nvSpPr>
@@ -3213,7 +3213,7 @@
         </p:sp>
         <p:sp>
           <p:nvSpPr>
-            <p:cNvPr id="6" name="footer-logo-5"/>
+            <p:cNvPr id="6" name="footer-logo-x reflection band 1"/>
             <p:cNvSpPr/>
             <p:nvPr/>
           </p:nvSpPr>
@@ -3259,7 +3259,7 @@
         </p:sp>
         <p:sp>
           <p:nvSpPr>
-            <p:cNvPr id="7" name="footer-logo-6"/>
+            <p:cNvPr id="7" name="footer-logo-x reflection band 2"/>
             <p:cNvSpPr/>
             <p:nvPr/>
           </p:nvSpPr>
@@ -3305,7 +3305,7 @@
         </p:sp>
         <p:sp>
           <p:nvSpPr>
-            <p:cNvPr id="8" name="footer-logo-7"/>
+            <p:cNvPr id="8" name="footer-logo-x reflection band 3"/>
             <p:cNvSpPr/>
             <p:nvPr/>
           </p:nvSpPr>
@@ -3351,7 +3351,7 @@
         </p:sp>
         <p:sp>
           <p:nvSpPr>
-            <p:cNvPr id="9" name="footer-logo-8"/>
+            <p:cNvPr id="9" name="footer-logo-x reflection band 4"/>
             <p:cNvSpPr/>
             <p:nvPr/>
           </p:nvSpPr>
@@ -3406,7 +3406,7 @@
         </p:sp>
         <p:sp>
           <p:nvSpPr>
-            <p:cNvPr id="10" name="footer-logo-9"/>
+            <p:cNvPr id="10" name="footer-logo-x reflection band 5"/>
             <p:cNvSpPr/>
             <p:nvPr/>
           </p:nvSpPr>
@@ -3464,7 +3464,7 @@
         </p:sp>
         <p:sp>
           <p:nvSpPr>
-            <p:cNvPr id="11" name="footer-logo-10"/>
+            <p:cNvPr id="11" name="footer-logo-x reflection band 6"/>
             <p:cNvSpPr/>
             <p:nvPr/>
           </p:nvSpPr>
@@ -3522,7 +3522,7 @@
         </p:sp>
         <p:sp>
           <p:nvSpPr>
-            <p:cNvPr id="12" name="footer-logo-11"/>
+            <p:cNvPr id="12" name="footer-logo-x reflection band 7"/>
             <p:cNvSpPr/>
             <p:nvPr/>
           </p:nvSpPr>
@@ -3580,7 +3580,7 @@
         </p:sp>
         <p:sp>
           <p:nvSpPr>
-            <p:cNvPr id="13" name="footer-logo-12"/>
+            <p:cNvPr id="13" name="footer-logo-l"/>
             <p:cNvSpPr/>
             <p:nvPr/>
           </p:nvSpPr>
@@ -3626,7 +3626,7 @@
         </p:sp>
         <p:sp>
           <p:nvSpPr>
-            <p:cNvPr id="14" name="footer-logo-13"/>
+            <p:cNvPr id="14" name="footer-logo-l reflection band 1"/>
             <p:cNvSpPr/>
             <p:nvPr/>
           </p:nvSpPr>
@@ -3672,7 +3672,7 @@
         </p:sp>
         <p:sp>
           <p:nvSpPr>
-            <p:cNvPr id="15" name="footer-logo-14"/>
+            <p:cNvPr id="15" name="footer-logo-l reflection band 2"/>
             <p:cNvSpPr/>
             <p:nvPr/>
           </p:nvSpPr>
@@ -3718,7 +3718,7 @@
         </p:sp>
         <p:sp>
           <p:nvSpPr>
-            <p:cNvPr id="16" name="footer-logo-15"/>
+            <p:cNvPr id="16" name="footer-logo-l reflection band 3"/>
             <p:cNvSpPr/>
             <p:nvPr/>
           </p:nvSpPr>
@@ -3764,7 +3764,7 @@
         </p:sp>
         <p:sp>
           <p:nvSpPr>
-            <p:cNvPr id="17" name="footer-logo-16"/>
+            <p:cNvPr id="17" name="footer-logo-l reflection band 4"/>
             <p:cNvSpPr/>
             <p:nvPr/>
           </p:nvSpPr>
@@ -3810,7 +3810,7 @@
         </p:sp>
         <p:sp>
           <p:nvSpPr>
-            <p:cNvPr id="18" name="footer-logo-17"/>
+            <p:cNvPr id="18" name="footer-logo-l reflection band 5"/>
             <p:cNvSpPr/>
             <p:nvPr/>
           </p:nvSpPr>
@@ -3856,7 +3856,7 @@
         </p:sp>
         <p:sp>
           <p:nvSpPr>
-            <p:cNvPr id="19" name="footer-logo-18"/>
+            <p:cNvPr id="19" name="footer-logo-l reflection band 6"/>
             <p:cNvSpPr/>
             <p:nvPr/>
           </p:nvSpPr>
@@ -3902,7 +3902,7 @@
         </p:sp>
         <p:sp>
           <p:nvSpPr>
-            <p:cNvPr id="20" name="footer-logo-19"/>
+            <p:cNvPr id="20" name="footer-logo-l reflection band 7"/>
             <p:cNvSpPr/>
             <p:nvPr/>
           </p:nvSpPr>
@@ -4785,7 +4785,7 @@
         </p:grpSpPr>
         <p:sp>
           <p:nvSpPr>
-            <p:cNvPr id="2" name="footer-logo-1"/>
+            <p:cNvPr id="2" name="footer-logo-v"/>
             <p:cNvSpPr/>
             <p:nvPr/>
           </p:nvSpPr>
@@ -4840,7 +4840,7 @@
         </p:sp>
         <p:sp>
           <p:nvSpPr>
-            <p:cNvPr id="3" name="footer-logo-2"/>
+            <p:cNvPr id="3" name="footer-logo-i stem"/>
             <p:cNvSpPr/>
             <p:nvPr/>
           </p:nvSpPr>
@@ -4886,7 +4886,7 @@
         </p:sp>
         <p:sp>
           <p:nvSpPr>
-            <p:cNvPr id="4" name="footer-logo-3"/>
+            <p:cNvPr id="4" name="footer-logo-i dot"/>
             <p:cNvSpPr/>
             <p:nvPr/>
           </p:nvSpPr>
@@ -4932,7 +4932,7 @@
         </p:sp>
         <p:sp>
           <p:nvSpPr>
-            <p:cNvPr id="5" name="footer-logo-4"/>
+            <p:cNvPr id="5" name="footer-logo-x"/>
             <p:cNvSpPr/>
             <p:nvPr/>
           </p:nvSpPr>
@@ -4987,7 +4987,7 @@
         </p:sp>
         <p:sp>
           <p:nvSpPr>
-            <p:cNvPr id="6" name="footer-logo-5"/>
+            <p:cNvPr id="6" name="footer-logo-x reflection band 1"/>
             <p:cNvSpPr/>
             <p:nvPr/>
           </p:nvSpPr>
@@ -5033,7 +5033,7 @@
         </p:sp>
         <p:sp>
           <p:nvSpPr>
-            <p:cNvPr id="7" name="footer-logo-6"/>
+            <p:cNvPr id="7" name="footer-logo-x reflection band 2"/>
             <p:cNvSpPr/>
             <p:nvPr/>
           </p:nvSpPr>
@@ -5079,7 +5079,7 @@
         </p:sp>
         <p:sp>
           <p:nvSpPr>
-            <p:cNvPr id="8" name="footer-logo-7"/>
+            <p:cNvPr id="8" name="footer-logo-x reflection band 3"/>
             <p:cNvSpPr/>
             <p:nvPr/>
           </p:nvSpPr>
@@ -5125,7 +5125,7 @@
         </p:sp>
         <p:sp>
           <p:nvSpPr>
-            <p:cNvPr id="9" name="footer-logo-8"/>
+            <p:cNvPr id="9" name="footer-logo-x reflection band 4"/>
             <p:cNvSpPr/>
             <p:nvPr/>
           </p:nvSpPr>
@@ -5180,7 +5180,7 @@
         </p:sp>
         <p:sp>
           <p:nvSpPr>
-            <p:cNvPr id="10" name="footer-logo-9"/>
+            <p:cNvPr id="10" name="footer-logo-x reflection band 5"/>
             <p:cNvSpPr/>
             <p:nvPr/>
           </p:nvSpPr>
@@ -5238,7 +5238,7 @@
         </p:sp>
         <p:sp>
           <p:nvSpPr>
-            <p:cNvPr id="11" name="footer-logo-10"/>
+            <p:cNvPr id="11" name="footer-logo-x reflection band 6"/>
             <p:cNvSpPr/>
             <p:nvPr/>
           </p:nvSpPr>
@@ -5296,7 +5296,7 @@
         </p:sp>
         <p:sp>
           <p:nvSpPr>
-            <p:cNvPr id="12" name="footer-logo-11"/>
+            <p:cNvPr id="12" name="footer-logo-x reflection band 7"/>
             <p:cNvSpPr/>
             <p:nvPr/>
           </p:nvSpPr>
@@ -5354,7 +5354,7 @@
         </p:sp>
         <p:sp>
           <p:nvSpPr>
-            <p:cNvPr id="13" name="footer-logo-12"/>
+            <p:cNvPr id="13" name="footer-logo-l"/>
             <p:cNvSpPr/>
             <p:nvPr/>
           </p:nvSpPr>
@@ -5400,7 +5400,7 @@
         </p:sp>
         <p:sp>
           <p:nvSpPr>
-            <p:cNvPr id="14" name="footer-logo-13"/>
+            <p:cNvPr id="14" name="footer-logo-l reflection band 1"/>
             <p:cNvSpPr/>
             <p:nvPr/>
           </p:nvSpPr>
@@ -5446,7 +5446,7 @@
         </p:sp>
         <p:sp>
           <p:nvSpPr>
-            <p:cNvPr id="15" name="footer-logo-14"/>
+            <p:cNvPr id="15" name="footer-logo-l reflection band 2"/>
             <p:cNvSpPr/>
             <p:nvPr/>
           </p:nvSpPr>
@@ -5492,7 +5492,7 @@
         </p:sp>
         <p:sp>
           <p:nvSpPr>
-            <p:cNvPr id="16" name="footer-logo-15"/>
+            <p:cNvPr id="16" name="footer-logo-l reflection band 3"/>
             <p:cNvSpPr/>
             <p:nvPr/>
           </p:nvSpPr>
@@ -5538,7 +5538,7 @@
         </p:sp>
         <p:sp>
           <p:nvSpPr>
-            <p:cNvPr id="17" name="footer-logo-16"/>
+            <p:cNvPr id="17" name="footer-logo-l reflection band 4"/>
             <p:cNvSpPr/>
             <p:nvPr/>
           </p:nvSpPr>
@@ -5584,7 +5584,7 @@
         </p:sp>
         <p:sp>
           <p:nvSpPr>
-            <p:cNvPr id="18" name="footer-logo-17"/>
+            <p:cNvPr id="18" name="footer-logo-l reflection band 5"/>
             <p:cNvSpPr/>
             <p:nvPr/>
           </p:nvSpPr>
@@ -5630,7 +5630,7 @@
         </p:sp>
         <p:sp>
           <p:nvSpPr>
-            <p:cNvPr id="19" name="footer-logo-18"/>
+            <p:cNvPr id="19" name="footer-logo-l reflection band 6"/>
             <p:cNvSpPr/>
             <p:nvPr/>
           </p:nvSpPr>
@@ -5676,7 +5676,7 @@
         </p:sp>
         <p:sp>
           <p:nvSpPr>
-            <p:cNvPr id="20" name="footer-logo-19"/>
+            <p:cNvPr id="20" name="footer-logo-l reflection band 7"/>
             <p:cNvSpPr/>
             <p:nvPr/>
           </p:nvSpPr>
@@ -6400,7 +6400,7 @@
         </p:grpSpPr>
         <p:sp>
           <p:nvSpPr>
-            <p:cNvPr id="2" name="footer-logo-1"/>
+            <p:cNvPr id="2" name="footer-logo-v"/>
             <p:cNvSpPr/>
             <p:nvPr/>
           </p:nvSpPr>
@@ -6455,7 +6455,7 @@
         </p:sp>
         <p:sp>
           <p:nvSpPr>
-            <p:cNvPr id="3" name="footer-logo-2"/>
+            <p:cNvPr id="3" name="footer-logo-i stem"/>
             <p:cNvSpPr/>
             <p:nvPr/>
           </p:nvSpPr>
@@ -6501,7 +6501,7 @@
         </p:sp>
         <p:sp>
           <p:nvSpPr>
-            <p:cNvPr id="4" name="footer-logo-3"/>
+            <p:cNvPr id="4" name="footer-logo-i dot"/>
             <p:cNvSpPr/>
             <p:nvPr/>
           </p:nvSpPr>
@@ -6547,7 +6547,7 @@
         </p:sp>
         <p:sp>
           <p:nvSpPr>
-            <p:cNvPr id="5" name="footer-logo-4"/>
+            <p:cNvPr id="5" name="footer-logo-x"/>
             <p:cNvSpPr/>
             <p:nvPr/>
           </p:nvSpPr>
@@ -6602,7 +6602,7 @@
         </p:sp>
         <p:sp>
           <p:nvSpPr>
-            <p:cNvPr id="6" name="footer-logo-5"/>
+            <p:cNvPr id="6" name="footer-logo-x reflection band 1"/>
             <p:cNvSpPr/>
             <p:nvPr/>
           </p:nvSpPr>
@@ -6648,7 +6648,7 @@
         </p:sp>
         <p:sp>
           <p:nvSpPr>
-            <p:cNvPr id="7" name="footer-logo-6"/>
+            <p:cNvPr id="7" name="footer-logo-x reflection band 2"/>
             <p:cNvSpPr/>
             <p:nvPr/>
           </p:nvSpPr>
@@ -6694,7 +6694,7 @@
         </p:sp>
         <p:sp>
           <p:nvSpPr>
-            <p:cNvPr id="8" name="footer-logo-7"/>
+            <p:cNvPr id="8" name="footer-logo-x reflection band 3"/>
             <p:cNvSpPr/>
             <p:nvPr/>
           </p:nvSpPr>
@@ -6740,7 +6740,7 @@
         </p:sp>
         <p:sp>
           <p:nvSpPr>
-            <p:cNvPr id="9" name="footer-logo-8"/>
+            <p:cNvPr id="9" name="footer-logo-x reflection band 4"/>
             <p:cNvSpPr/>
             <p:nvPr/>
           </p:nvSpPr>
@@ -6795,7 +6795,7 @@
         </p:sp>
         <p:sp>
           <p:nvSpPr>
-            <p:cNvPr id="10" name="footer-logo-9"/>
+            <p:cNvPr id="10" name="footer-logo-x reflection band 5"/>
             <p:cNvSpPr/>
             <p:nvPr/>
           </p:nvSpPr>
@@ -6853,7 +6853,7 @@
         </p:sp>
         <p:sp>
           <p:nvSpPr>
-            <p:cNvPr id="11" name="footer-logo-10"/>
+            <p:cNvPr id="11" name="footer-logo-x reflection band 6"/>
             <p:cNvSpPr/>
             <p:nvPr/>
           </p:nvSpPr>
@@ -6911,7 +6911,7 @@
         </p:sp>
         <p:sp>
           <p:nvSpPr>
-            <p:cNvPr id="12" name="footer-logo-11"/>
+            <p:cNvPr id="12" name="footer-logo-x reflection band 7"/>
             <p:cNvSpPr/>
             <p:nvPr/>
           </p:nvSpPr>
@@ -6969,7 +6969,7 @@
         </p:sp>
         <p:sp>
           <p:nvSpPr>
-            <p:cNvPr id="13" name="footer-logo-12"/>
+            <p:cNvPr id="13" name="footer-logo-l"/>
             <p:cNvSpPr/>
             <p:nvPr/>
           </p:nvSpPr>
@@ -7015,7 +7015,7 @@
         </p:sp>
         <p:sp>
           <p:nvSpPr>
-            <p:cNvPr id="14" name="footer-logo-13"/>
+            <p:cNvPr id="14" name="footer-logo-l reflection band 1"/>
             <p:cNvSpPr/>
             <p:nvPr/>
           </p:nvSpPr>
@@ -7061,7 +7061,7 @@
         </p:sp>
         <p:sp>
           <p:nvSpPr>
-            <p:cNvPr id="15" name="footer-logo-14"/>
+            <p:cNvPr id="15" name="footer-logo-l reflection band 2"/>
             <p:cNvSpPr/>
             <p:nvPr/>
           </p:nvSpPr>
@@ -7107,7 +7107,7 @@
         </p:sp>
         <p:sp>
           <p:nvSpPr>
-            <p:cNvPr id="16" name="footer-logo-15"/>
+            <p:cNvPr id="16" name="footer-logo-l reflection band 3"/>
             <p:cNvSpPr/>
             <p:nvPr/>
           </p:nvSpPr>
@@ -7153,7 +7153,7 @@
         </p:sp>
         <p:sp>
           <p:nvSpPr>
-            <p:cNvPr id="17" name="footer-logo-16"/>
+            <p:cNvPr id="17" name="footer-logo-l reflection band 4"/>
             <p:cNvSpPr/>
             <p:nvPr/>
           </p:nvSpPr>
@@ -7199,7 +7199,7 @@
         </p:sp>
         <p:sp>
           <p:nvSpPr>
-            <p:cNvPr id="18" name="footer-logo-17"/>
+            <p:cNvPr id="18" name="footer-logo-l reflection band 5"/>
             <p:cNvSpPr/>
             <p:nvPr/>
           </p:nvSpPr>
@@ -7245,7 +7245,7 @@
         </p:sp>
         <p:sp>
           <p:nvSpPr>
-            <p:cNvPr id="19" name="footer-logo-18"/>
+            <p:cNvPr id="19" name="footer-logo-l reflection band 6"/>
             <p:cNvSpPr/>
             <p:nvPr/>
           </p:nvSpPr>
@@ -7291,7 +7291,7 @@
         </p:sp>
         <p:sp>
           <p:nvSpPr>
-            <p:cNvPr id="20" name="footer-logo-19"/>
+            <p:cNvPr id="20" name="footer-logo-l reflection band 7"/>
             <p:cNvSpPr/>
             <p:nvPr/>
           </p:nvSpPr>
@@ -7508,12 +7508,12 @@
           </p:nvSpPr>
           <p:spPr>
             <a:xfrm>
-              <a:off x="12700" y="12700"/>
-              <a:ext cx="10388600" cy="1676400"/>
+              <a:off x="6350" y="6350"/>
+              <a:ext cx="10401300" cy="1689100"/>
             </a:xfrm>
             <a:prstGeom prst="roundRect">
               <a:avLst>
-                <a:gd name="adj" fmla="val 6439"/>
+                <a:gd name="adj" fmla="val 6391"/>
               </a:avLst>
             </a:prstGeom>
             <a:solidFill>
@@ -7976,7 +7976,7 @@
         </p:grpSpPr>
         <p:sp>
           <p:nvSpPr>
-            <p:cNvPr id="2" name="footer-logo-1"/>
+            <p:cNvPr id="2" name="footer-logo-v"/>
             <p:cNvSpPr/>
             <p:nvPr/>
           </p:nvSpPr>
@@ -8031,7 +8031,7 @@
         </p:sp>
         <p:sp>
           <p:nvSpPr>
-            <p:cNvPr id="3" name="footer-logo-2"/>
+            <p:cNvPr id="3" name="footer-logo-i stem"/>
             <p:cNvSpPr/>
             <p:nvPr/>
           </p:nvSpPr>
@@ -8077,7 +8077,7 @@
         </p:sp>
         <p:sp>
           <p:nvSpPr>
-            <p:cNvPr id="4" name="footer-logo-3"/>
+            <p:cNvPr id="4" name="footer-logo-i dot"/>
             <p:cNvSpPr/>
             <p:nvPr/>
           </p:nvSpPr>
@@ -8123,7 +8123,7 @@
         </p:sp>
         <p:sp>
           <p:nvSpPr>
-            <p:cNvPr id="5" name="footer-logo-4"/>
+            <p:cNvPr id="5" name="footer-logo-x"/>
             <p:cNvSpPr/>
             <p:nvPr/>
           </p:nvSpPr>
@@ -8178,7 +8178,7 @@
         </p:sp>
         <p:sp>
           <p:nvSpPr>
-            <p:cNvPr id="6" name="footer-logo-5"/>
+            <p:cNvPr id="6" name="footer-logo-x reflection band 1"/>
             <p:cNvSpPr/>
             <p:nvPr/>
           </p:nvSpPr>
@@ -8224,7 +8224,7 @@
         </p:sp>
         <p:sp>
           <p:nvSpPr>
-            <p:cNvPr id="7" name="footer-logo-6"/>
+            <p:cNvPr id="7" name="footer-logo-x reflection band 2"/>
             <p:cNvSpPr/>
             <p:nvPr/>
           </p:nvSpPr>
@@ -8270,7 +8270,7 @@
         </p:sp>
         <p:sp>
           <p:nvSpPr>
-            <p:cNvPr id="8" name="footer-logo-7"/>
+            <p:cNvPr id="8" name="footer-logo-x reflection band 3"/>
             <p:cNvSpPr/>
             <p:nvPr/>
           </p:nvSpPr>
@@ -8316,7 +8316,7 @@
         </p:sp>
         <p:sp>
           <p:nvSpPr>
-            <p:cNvPr id="9" name="footer-logo-8"/>
+            <p:cNvPr id="9" name="footer-logo-x reflection band 4"/>
             <p:cNvSpPr/>
             <p:nvPr/>
           </p:nvSpPr>
@@ -8371,7 +8371,7 @@
         </p:sp>
         <p:sp>
           <p:nvSpPr>
-            <p:cNvPr id="10" name="footer-logo-9"/>
+            <p:cNvPr id="10" name="footer-logo-x reflection band 5"/>
             <p:cNvSpPr/>
             <p:nvPr/>
           </p:nvSpPr>
@@ -8429,7 +8429,7 @@
         </p:sp>
         <p:sp>
           <p:nvSpPr>
-            <p:cNvPr id="11" name="footer-logo-10"/>
+            <p:cNvPr id="11" name="footer-logo-x reflection band 6"/>
             <p:cNvSpPr/>
             <p:nvPr/>
           </p:nvSpPr>
@@ -8487,7 +8487,7 @@
         </p:sp>
         <p:sp>
           <p:nvSpPr>
-            <p:cNvPr id="12" name="footer-logo-11"/>
+            <p:cNvPr id="12" name="footer-logo-x reflection band 7"/>
             <p:cNvSpPr/>
             <p:nvPr/>
           </p:nvSpPr>
@@ -8545,7 +8545,7 @@
         </p:sp>
         <p:sp>
           <p:nvSpPr>
-            <p:cNvPr id="13" name="footer-logo-12"/>
+            <p:cNvPr id="13" name="footer-logo-l"/>
             <p:cNvSpPr/>
             <p:nvPr/>
           </p:nvSpPr>
@@ -8591,7 +8591,7 @@
         </p:sp>
         <p:sp>
           <p:nvSpPr>
-            <p:cNvPr id="14" name="footer-logo-13"/>
+            <p:cNvPr id="14" name="footer-logo-l reflection band 1"/>
             <p:cNvSpPr/>
             <p:nvPr/>
           </p:nvSpPr>
@@ -8637,7 +8637,7 @@
         </p:sp>
         <p:sp>
           <p:nvSpPr>
-            <p:cNvPr id="15" name="footer-logo-14"/>
+            <p:cNvPr id="15" name="footer-logo-l reflection band 2"/>
             <p:cNvSpPr/>
             <p:nvPr/>
           </p:nvSpPr>
@@ -8683,7 +8683,7 @@
         </p:sp>
         <p:sp>
           <p:nvSpPr>
-            <p:cNvPr id="16" name="footer-logo-15"/>
+            <p:cNvPr id="16" name="footer-logo-l reflection band 3"/>
             <p:cNvSpPr/>
             <p:nvPr/>
           </p:nvSpPr>
@@ -8729,7 +8729,7 @@
         </p:sp>
         <p:sp>
           <p:nvSpPr>
-            <p:cNvPr id="17" name="footer-logo-16"/>
+            <p:cNvPr id="17" name="footer-logo-l reflection band 4"/>
             <p:cNvSpPr/>
             <p:nvPr/>
           </p:nvSpPr>
@@ -8775,7 +8775,7 @@
         </p:sp>
         <p:sp>
           <p:nvSpPr>
-            <p:cNvPr id="18" name="footer-logo-17"/>
+            <p:cNvPr id="18" name="footer-logo-l reflection band 5"/>
             <p:cNvSpPr/>
             <p:nvPr/>
           </p:nvSpPr>
@@ -8821,7 +8821,7 @@
         </p:sp>
         <p:sp>
           <p:nvSpPr>
-            <p:cNvPr id="19" name="footer-logo-18"/>
+            <p:cNvPr id="19" name="footer-logo-l reflection band 6"/>
             <p:cNvSpPr/>
             <p:nvPr/>
           </p:nvSpPr>
@@ -8867,7 +8867,7 @@
         </p:sp>
         <p:sp>
           <p:nvSpPr>
-            <p:cNvPr id="20" name="footer-logo-19"/>
+            <p:cNvPr id="20" name="footer-logo-l reflection band 7"/>
             <p:cNvSpPr/>
             <p:nvPr/>
           </p:nvSpPr>
@@ -9591,7 +9591,7 @@
         </p:grpSpPr>
         <p:sp>
           <p:nvSpPr>
-            <p:cNvPr id="2" name="footer-logo-1"/>
+            <p:cNvPr id="2" name="footer-logo-v"/>
             <p:cNvSpPr/>
             <p:nvPr/>
           </p:nvSpPr>
@@ -9646,7 +9646,7 @@
         </p:sp>
         <p:sp>
           <p:nvSpPr>
-            <p:cNvPr id="3" name="footer-logo-2"/>
+            <p:cNvPr id="3" name="footer-logo-i stem"/>
             <p:cNvSpPr/>
             <p:nvPr/>
           </p:nvSpPr>
@@ -9692,7 +9692,7 @@
         </p:sp>
         <p:sp>
           <p:nvSpPr>
-            <p:cNvPr id="4" name="footer-logo-3"/>
+            <p:cNvPr id="4" name="footer-logo-i dot"/>
             <p:cNvSpPr/>
             <p:nvPr/>
           </p:nvSpPr>
@@ -9738,7 +9738,7 @@
         </p:sp>
         <p:sp>
           <p:nvSpPr>
-            <p:cNvPr id="5" name="footer-logo-4"/>
+            <p:cNvPr id="5" name="footer-logo-x"/>
             <p:cNvSpPr/>
             <p:nvPr/>
           </p:nvSpPr>
@@ -9793,7 +9793,7 @@
         </p:sp>
         <p:sp>
           <p:nvSpPr>
-            <p:cNvPr id="6" name="footer-logo-5"/>
+            <p:cNvPr id="6" name="footer-logo-x reflection band 1"/>
             <p:cNvSpPr/>
             <p:nvPr/>
           </p:nvSpPr>
@@ -9839,7 +9839,7 @@
         </p:sp>
         <p:sp>
           <p:nvSpPr>
-            <p:cNvPr id="7" name="footer-logo-6"/>
+            <p:cNvPr id="7" name="footer-logo-x reflection band 2"/>
             <p:cNvSpPr/>
             <p:nvPr/>
           </p:nvSpPr>
@@ -9885,7 +9885,7 @@
         </p:sp>
         <p:sp>
           <p:nvSpPr>
-            <p:cNvPr id="8" name="footer-logo-7"/>
+            <p:cNvPr id="8" name="footer-logo-x reflection band 3"/>
             <p:cNvSpPr/>
             <p:nvPr/>
           </p:nvSpPr>
@@ -9931,7 +9931,7 @@
         </p:sp>
         <p:sp>
           <p:nvSpPr>
-            <p:cNvPr id="9" name="footer-logo-8"/>
+            <p:cNvPr id="9" name="footer-logo-x reflection band 4"/>
             <p:cNvSpPr/>
             <p:nvPr/>
           </p:nvSpPr>
@@ -9986,7 +9986,7 @@
         </p:sp>
         <p:sp>
           <p:nvSpPr>
-            <p:cNvPr id="10" name="footer-logo-9"/>
+            <p:cNvPr id="10" name="footer-logo-x reflection band 5"/>
             <p:cNvSpPr/>
             <p:nvPr/>
           </p:nvSpPr>
@@ -10044,7 +10044,7 @@
         </p:sp>
         <p:sp>
           <p:nvSpPr>
-            <p:cNvPr id="11" name="footer-logo-10"/>
+            <p:cNvPr id="11" name="footer-logo-x reflection band 6"/>
             <p:cNvSpPr/>
             <p:nvPr/>
           </p:nvSpPr>
@@ -10102,7 +10102,7 @@
         </p:sp>
         <p:sp>
           <p:nvSpPr>
-            <p:cNvPr id="12" name="footer-logo-11"/>
+            <p:cNvPr id="12" name="footer-logo-x reflection band 7"/>
             <p:cNvSpPr/>
             <p:nvPr/>
           </p:nvSpPr>
@@ -10160,7 +10160,7 @@
         </p:sp>
         <p:sp>
           <p:nvSpPr>
-            <p:cNvPr id="13" name="footer-logo-12"/>
+            <p:cNvPr id="13" name="footer-logo-l"/>
             <p:cNvSpPr/>
             <p:nvPr/>
           </p:nvSpPr>
@@ -10206,7 +10206,7 @@
         </p:sp>
         <p:sp>
           <p:nvSpPr>
-            <p:cNvPr id="14" name="footer-logo-13"/>
+            <p:cNvPr id="14" name="footer-logo-l reflection band 1"/>
             <p:cNvSpPr/>
             <p:nvPr/>
           </p:nvSpPr>
@@ -10252,7 +10252,7 @@
         </p:sp>
         <p:sp>
           <p:nvSpPr>
-            <p:cNvPr id="15" name="footer-logo-14"/>
+            <p:cNvPr id="15" name="footer-logo-l reflection band 2"/>
             <p:cNvSpPr/>
             <p:nvPr/>
           </p:nvSpPr>
@@ -10298,7 +10298,7 @@
         </p:sp>
         <p:sp>
           <p:nvSpPr>
-            <p:cNvPr id="16" name="footer-logo-15"/>
+            <p:cNvPr id="16" name="footer-logo-l reflection band 3"/>
             <p:cNvSpPr/>
             <p:nvPr/>
           </p:nvSpPr>
@@ -10344,7 +10344,7 @@
         </p:sp>
         <p:sp>
           <p:nvSpPr>
-            <p:cNvPr id="17" name="footer-logo-16"/>
+            <p:cNvPr id="17" name="footer-logo-l reflection band 4"/>
             <p:cNvSpPr/>
             <p:nvPr/>
           </p:nvSpPr>
@@ -10390,7 +10390,7 @@
         </p:sp>
         <p:sp>
           <p:nvSpPr>
-            <p:cNvPr id="18" name="footer-logo-17"/>
+            <p:cNvPr id="18" name="footer-logo-l reflection band 5"/>
             <p:cNvSpPr/>
             <p:nvPr/>
           </p:nvSpPr>
@@ -10436,7 +10436,7 @@
         </p:sp>
         <p:sp>
           <p:nvSpPr>
-            <p:cNvPr id="19" name="footer-logo-18"/>
+            <p:cNvPr id="19" name="footer-logo-l reflection band 6"/>
             <p:cNvSpPr/>
             <p:nvPr/>
           </p:nvSpPr>
@@ -10482,7 +10482,7 @@
         </p:sp>
         <p:sp>
           <p:nvSpPr>
-            <p:cNvPr id="20" name="footer-logo-19"/>
+            <p:cNvPr id="20" name="footer-logo-l reflection band 7"/>
             <p:cNvSpPr/>
             <p:nvPr/>
           </p:nvSpPr>
@@ -10919,12 +10919,12 @@
           </p:nvSpPr>
           <p:spPr>
             <a:xfrm>
-              <a:off x="57150" y="190500"/>
-              <a:ext cx="1460500" cy="508000"/>
+              <a:off x="47625" y="180975"/>
+              <a:ext cx="1479550" cy="527050"/>
             </a:xfrm>
             <a:prstGeom prst="roundRect">
               <a:avLst>
-                <a:gd name="adj" fmla="val 13875"/>
+                <a:gd name="adj" fmla="val 13373"/>
               </a:avLst>
             </a:prstGeom>
             <a:solidFill>
@@ -10945,12 +10945,12 @@
           </p:nvSpPr>
           <p:spPr>
             <a:xfrm>
-              <a:off x="2235200" y="190500"/>
-              <a:ext cx="1206500" cy="508000"/>
+              <a:off x="2225675" y="180975"/>
+              <a:ext cx="1225550" cy="527050"/>
             </a:xfrm>
             <a:prstGeom prst="roundRect">
               <a:avLst>
-                <a:gd name="adj" fmla="val 13875"/>
+                <a:gd name="adj" fmla="val 13373"/>
               </a:avLst>
             </a:prstGeom>
             <a:solidFill>
@@ -11019,12 +11019,12 @@
           </p:nvSpPr>
           <p:spPr>
             <a:xfrm>
-              <a:off x="6648450" y="222250"/>
-              <a:ext cx="1549400" cy="444500"/>
+              <a:off x="6638925" y="212725"/>
+              <a:ext cx="1568450" cy="463550"/>
             </a:xfrm>
             <a:prstGeom prst="roundRect">
               <a:avLst>
-                <a:gd name="adj" fmla="val 15857"/>
+                <a:gd name="adj" fmla="val 15205"/>
               </a:avLst>
             </a:prstGeom>
             <a:solidFill>
@@ -11045,12 +11045,12 @@
           </p:nvSpPr>
           <p:spPr>
             <a:xfrm>
-              <a:off x="8915400" y="190500"/>
-              <a:ext cx="1333500" cy="508000"/>
+              <a:off x="8905875" y="180975"/>
+              <a:ext cx="1352550" cy="527050"/>
             </a:xfrm>
             <a:prstGeom prst="roundRect">
               <a:avLst>
-                <a:gd name="adj" fmla="val 13875"/>
+                <a:gd name="adj" fmla="val 13373"/>
               </a:avLst>
             </a:prstGeom>
             <a:solidFill>
@@ -11406,7 +11406,7 @@
         </p:grpSpPr>
         <p:sp>
           <p:nvSpPr>
-            <p:cNvPr id="2" name="footer-logo-1"/>
+            <p:cNvPr id="2" name="footer-logo-v"/>
             <p:cNvSpPr/>
             <p:nvPr/>
           </p:nvSpPr>
@@ -11461,7 +11461,7 @@
         </p:sp>
         <p:sp>
           <p:nvSpPr>
-            <p:cNvPr id="3" name="footer-logo-2"/>
+            <p:cNvPr id="3" name="footer-logo-i stem"/>
             <p:cNvSpPr/>
             <p:nvPr/>
           </p:nvSpPr>
@@ -11507,7 +11507,7 @@
         </p:sp>
         <p:sp>
           <p:nvSpPr>
-            <p:cNvPr id="4" name="footer-logo-3"/>
+            <p:cNvPr id="4" name="footer-logo-i dot"/>
             <p:cNvSpPr/>
             <p:nvPr/>
           </p:nvSpPr>
@@ -11553,7 +11553,7 @@
         </p:sp>
         <p:sp>
           <p:nvSpPr>
-            <p:cNvPr id="5" name="footer-logo-4"/>
+            <p:cNvPr id="5" name="footer-logo-x"/>
             <p:cNvSpPr/>
             <p:nvPr/>
           </p:nvSpPr>
@@ -11608,7 +11608,7 @@
         </p:sp>
         <p:sp>
           <p:nvSpPr>
-            <p:cNvPr id="6" name="footer-logo-5"/>
+            <p:cNvPr id="6" name="footer-logo-x reflection band 1"/>
             <p:cNvSpPr/>
             <p:nvPr/>
           </p:nvSpPr>
@@ -11654,7 +11654,7 @@
         </p:sp>
         <p:sp>
           <p:nvSpPr>
-            <p:cNvPr id="7" name="footer-logo-6"/>
+            <p:cNvPr id="7" name="footer-logo-x reflection band 2"/>
             <p:cNvSpPr/>
             <p:nvPr/>
           </p:nvSpPr>
@@ -11700,7 +11700,7 @@
         </p:sp>
         <p:sp>
           <p:nvSpPr>
-            <p:cNvPr id="8" name="footer-logo-7"/>
+            <p:cNvPr id="8" name="footer-logo-x reflection band 3"/>
             <p:cNvSpPr/>
             <p:nvPr/>
           </p:nvSpPr>
@@ -11746,7 +11746,7 @@
         </p:sp>
         <p:sp>
           <p:nvSpPr>
-            <p:cNvPr id="9" name="footer-logo-8"/>
+            <p:cNvPr id="9" name="footer-logo-x reflection band 4"/>
             <p:cNvSpPr/>
             <p:nvPr/>
           </p:nvSpPr>
@@ -11801,7 +11801,7 @@
         </p:sp>
         <p:sp>
           <p:nvSpPr>
-            <p:cNvPr id="10" name="footer-logo-9"/>
+            <p:cNvPr id="10" name="footer-logo-x reflection band 5"/>
             <p:cNvSpPr/>
             <p:nvPr/>
           </p:nvSpPr>
@@ -11859,7 +11859,7 @@
         </p:sp>
         <p:sp>
           <p:nvSpPr>
-            <p:cNvPr id="11" name="footer-logo-10"/>
+            <p:cNvPr id="11" name="footer-logo-x reflection band 6"/>
             <p:cNvSpPr/>
             <p:nvPr/>
           </p:nvSpPr>
@@ -11917,7 +11917,7 @@
         </p:sp>
         <p:sp>
           <p:nvSpPr>
-            <p:cNvPr id="12" name="footer-logo-11"/>
+            <p:cNvPr id="12" name="footer-logo-x reflection band 7"/>
             <p:cNvSpPr/>
             <p:nvPr/>
           </p:nvSpPr>
@@ -11975,7 +11975,7 @@
         </p:sp>
         <p:sp>
           <p:nvSpPr>
-            <p:cNvPr id="13" name="footer-logo-12"/>
+            <p:cNvPr id="13" name="footer-logo-l"/>
             <p:cNvSpPr/>
             <p:nvPr/>
           </p:nvSpPr>
@@ -12021,7 +12021,7 @@
         </p:sp>
         <p:sp>
           <p:nvSpPr>
-            <p:cNvPr id="14" name="footer-logo-13"/>
+            <p:cNvPr id="14" name="footer-logo-l reflection band 1"/>
             <p:cNvSpPr/>
             <p:nvPr/>
           </p:nvSpPr>
@@ -12067,7 +12067,7 @@
         </p:sp>
         <p:sp>
           <p:nvSpPr>
-            <p:cNvPr id="15" name="footer-logo-14"/>
+            <p:cNvPr id="15" name="footer-logo-l reflection band 2"/>
             <p:cNvSpPr/>
             <p:nvPr/>
           </p:nvSpPr>
@@ -12113,7 +12113,7 @@
         </p:sp>
         <p:sp>
           <p:nvSpPr>
-            <p:cNvPr id="16" name="footer-logo-15"/>
+            <p:cNvPr id="16" name="footer-logo-l reflection band 3"/>
             <p:cNvSpPr/>
             <p:nvPr/>
           </p:nvSpPr>
@@ -12159,7 +12159,7 @@
         </p:sp>
         <p:sp>
           <p:nvSpPr>
-            <p:cNvPr id="17" name="footer-logo-16"/>
+            <p:cNvPr id="17" name="footer-logo-l reflection band 4"/>
             <p:cNvSpPr/>
             <p:nvPr/>
           </p:nvSpPr>
@@ -12205,7 +12205,7 @@
         </p:sp>
         <p:sp>
           <p:nvSpPr>
-            <p:cNvPr id="18" name="footer-logo-17"/>
+            <p:cNvPr id="18" name="footer-logo-l reflection band 5"/>
             <p:cNvSpPr/>
             <p:nvPr/>
           </p:nvSpPr>
@@ -12251,7 +12251,7 @@
         </p:sp>
         <p:sp>
           <p:nvSpPr>
-            <p:cNvPr id="19" name="footer-logo-18"/>
+            <p:cNvPr id="19" name="footer-logo-l reflection band 6"/>
             <p:cNvSpPr/>
             <p:nvPr/>
           </p:nvSpPr>
@@ -12297,7 +12297,7 @@
         </p:sp>
         <p:sp>
           <p:nvSpPr>
-            <p:cNvPr id="20" name="footer-logo-19"/>
+            <p:cNvPr id="20" name="footer-logo-l reflection band 7"/>
             <p:cNvSpPr/>
             <p:nvPr/>
           </p:nvSpPr>
@@ -13324,7 +13324,7 @@
         </p:grpSpPr>
         <p:sp>
           <p:nvSpPr>
-            <p:cNvPr id="2" name="footer-logo-1"/>
+            <p:cNvPr id="2" name="footer-logo-v"/>
             <p:cNvSpPr/>
             <p:nvPr/>
           </p:nvSpPr>
@@ -13379,7 +13379,7 @@
         </p:sp>
         <p:sp>
           <p:nvSpPr>
-            <p:cNvPr id="3" name="footer-logo-2"/>
+            <p:cNvPr id="3" name="footer-logo-i stem"/>
             <p:cNvSpPr/>
             <p:nvPr/>
           </p:nvSpPr>
@@ -13425,7 +13425,7 @@
         </p:sp>
         <p:sp>
           <p:nvSpPr>
-            <p:cNvPr id="4" name="footer-logo-3"/>
+            <p:cNvPr id="4" name="footer-logo-i dot"/>
             <p:cNvSpPr/>
             <p:nvPr/>
           </p:nvSpPr>
@@ -13471,7 +13471,7 @@
         </p:sp>
         <p:sp>
           <p:nvSpPr>
-            <p:cNvPr id="5" name="footer-logo-4"/>
+            <p:cNvPr id="5" name="footer-logo-x"/>
             <p:cNvSpPr/>
             <p:nvPr/>
           </p:nvSpPr>
@@ -13526,7 +13526,7 @@
         </p:sp>
         <p:sp>
           <p:nvSpPr>
-            <p:cNvPr id="6" name="footer-logo-5"/>
+            <p:cNvPr id="6" name="footer-logo-x reflection band 1"/>
             <p:cNvSpPr/>
             <p:nvPr/>
           </p:nvSpPr>
@@ -13572,7 +13572,7 @@
         </p:sp>
         <p:sp>
           <p:nvSpPr>
-            <p:cNvPr id="7" name="footer-logo-6"/>
+            <p:cNvPr id="7" name="footer-logo-x reflection band 2"/>
             <p:cNvSpPr/>
             <p:nvPr/>
           </p:nvSpPr>
@@ -13618,7 +13618,7 @@
         </p:sp>
         <p:sp>
           <p:nvSpPr>
-            <p:cNvPr id="8" name="footer-logo-7"/>
+            <p:cNvPr id="8" name="footer-logo-x reflection band 3"/>
             <p:cNvSpPr/>
             <p:nvPr/>
           </p:nvSpPr>
@@ -13664,7 +13664,7 @@
         </p:sp>
         <p:sp>
           <p:nvSpPr>
-            <p:cNvPr id="9" name="footer-logo-8"/>
+            <p:cNvPr id="9" name="footer-logo-x reflection band 4"/>
             <p:cNvSpPr/>
             <p:nvPr/>
           </p:nvSpPr>
@@ -13719,7 +13719,7 @@
         </p:sp>
         <p:sp>
           <p:nvSpPr>
-            <p:cNvPr id="10" name="footer-logo-9"/>
+            <p:cNvPr id="10" name="footer-logo-x reflection band 5"/>
             <p:cNvSpPr/>
             <p:nvPr/>
           </p:nvSpPr>
@@ -13777,7 +13777,7 @@
         </p:sp>
         <p:sp>
           <p:nvSpPr>
-            <p:cNvPr id="11" name="footer-logo-10"/>
+            <p:cNvPr id="11" name="footer-logo-x reflection band 6"/>
             <p:cNvSpPr/>
             <p:nvPr/>
           </p:nvSpPr>
@@ -13835,7 +13835,7 @@
         </p:sp>
         <p:sp>
           <p:nvSpPr>
-            <p:cNvPr id="12" name="footer-logo-11"/>
+            <p:cNvPr id="12" name="footer-logo-x reflection band 7"/>
             <p:cNvSpPr/>
             <p:nvPr/>
           </p:nvSpPr>
@@ -13893,7 +13893,7 @@
         </p:sp>
         <p:sp>
           <p:nvSpPr>
-            <p:cNvPr id="13" name="footer-logo-12"/>
+            <p:cNvPr id="13" name="footer-logo-l"/>
             <p:cNvSpPr/>
             <p:nvPr/>
           </p:nvSpPr>
@@ -13939,7 +13939,7 @@
         </p:sp>
         <p:sp>
           <p:nvSpPr>
-            <p:cNvPr id="14" name="footer-logo-13"/>
+            <p:cNvPr id="14" name="footer-logo-l reflection band 1"/>
             <p:cNvSpPr/>
             <p:nvPr/>
           </p:nvSpPr>
@@ -13985,7 +13985,7 @@
         </p:sp>
         <p:sp>
           <p:nvSpPr>
-            <p:cNvPr id="15" name="footer-logo-14"/>
+            <p:cNvPr id="15" name="footer-logo-l reflection band 2"/>
             <p:cNvSpPr/>
             <p:nvPr/>
           </p:nvSpPr>
@@ -14031,7 +14031,7 @@
         </p:sp>
         <p:sp>
           <p:nvSpPr>
-            <p:cNvPr id="16" name="footer-logo-15"/>
+            <p:cNvPr id="16" name="footer-logo-l reflection band 3"/>
             <p:cNvSpPr/>
             <p:nvPr/>
           </p:nvSpPr>
@@ -14077,7 +14077,7 @@
         </p:sp>
         <p:sp>
           <p:nvSpPr>
-            <p:cNvPr id="17" name="footer-logo-16"/>
+            <p:cNvPr id="17" name="footer-logo-l reflection band 4"/>
             <p:cNvSpPr/>
             <p:nvPr/>
           </p:nvSpPr>
@@ -14123,7 +14123,7 @@
         </p:sp>
         <p:sp>
           <p:nvSpPr>
-            <p:cNvPr id="18" name="footer-logo-17"/>
+            <p:cNvPr id="18" name="footer-logo-l reflection band 5"/>
             <p:cNvSpPr/>
             <p:nvPr/>
           </p:nvSpPr>
@@ -14169,7 +14169,7 @@
         </p:sp>
         <p:sp>
           <p:nvSpPr>
-            <p:cNvPr id="19" name="footer-logo-18"/>
+            <p:cNvPr id="19" name="footer-logo-l reflection band 6"/>
             <p:cNvSpPr/>
             <p:nvPr/>
           </p:nvSpPr>
@@ -14215,7 +14215,7 @@
         </p:sp>
         <p:sp>
           <p:nvSpPr>
-            <p:cNvPr id="20" name="footer-logo-19"/>
+            <p:cNvPr id="20" name="footer-logo-l reflection band 7"/>
             <p:cNvSpPr/>
             <p:nvPr/>
           </p:nvSpPr>
@@ -14678,7 +14678,7 @@
         </p:grpSpPr>
         <p:sp>
           <p:nvSpPr>
-            <p:cNvPr id="2" name="footer-logo-1"/>
+            <p:cNvPr id="2" name="footer-logo-v"/>
             <p:cNvSpPr/>
             <p:nvPr/>
           </p:nvSpPr>
@@ -14733,7 +14733,7 @@
         </p:sp>
         <p:sp>
           <p:nvSpPr>
-            <p:cNvPr id="3" name="footer-logo-2"/>
+            <p:cNvPr id="3" name="footer-logo-i stem"/>
             <p:cNvSpPr/>
             <p:nvPr/>
           </p:nvSpPr>
@@ -14779,7 +14779,7 @@
         </p:sp>
         <p:sp>
           <p:nvSpPr>
-            <p:cNvPr id="4" name="footer-logo-3"/>
+            <p:cNvPr id="4" name="footer-logo-i dot"/>
             <p:cNvSpPr/>
             <p:nvPr/>
           </p:nvSpPr>
@@ -14825,7 +14825,7 @@
         </p:sp>
         <p:sp>
           <p:nvSpPr>
-            <p:cNvPr id="5" name="footer-logo-4"/>
+            <p:cNvPr id="5" name="footer-logo-x"/>
             <p:cNvSpPr/>
             <p:nvPr/>
           </p:nvSpPr>
@@ -14880,7 +14880,7 @@
         </p:sp>
         <p:sp>
           <p:nvSpPr>
-            <p:cNvPr id="6" name="footer-logo-5"/>
+            <p:cNvPr id="6" name="footer-logo-x reflection band 1"/>
             <p:cNvSpPr/>
             <p:nvPr/>
           </p:nvSpPr>
@@ -14926,7 +14926,7 @@
         </p:sp>
         <p:sp>
           <p:nvSpPr>
-            <p:cNvPr id="7" name="footer-logo-6"/>
+            <p:cNvPr id="7" name="footer-logo-x reflection band 2"/>
             <p:cNvSpPr/>
             <p:nvPr/>
           </p:nvSpPr>
@@ -14972,7 +14972,7 @@
         </p:sp>
         <p:sp>
           <p:nvSpPr>
-            <p:cNvPr id="8" name="footer-logo-7"/>
+            <p:cNvPr id="8" name="footer-logo-x reflection band 3"/>
             <p:cNvSpPr/>
             <p:nvPr/>
           </p:nvSpPr>
@@ -15018,7 +15018,7 @@
         </p:sp>
         <p:sp>
           <p:nvSpPr>
-            <p:cNvPr id="9" name="footer-logo-8"/>
+            <p:cNvPr id="9" name="footer-logo-x reflection band 4"/>
             <p:cNvSpPr/>
             <p:nvPr/>
           </p:nvSpPr>
@@ -15073,7 +15073,7 @@
         </p:sp>
         <p:sp>
           <p:nvSpPr>
-            <p:cNvPr id="10" name="footer-logo-9"/>
+            <p:cNvPr id="10" name="footer-logo-x reflection band 5"/>
             <p:cNvSpPr/>
             <p:nvPr/>
           </p:nvSpPr>
@@ -15131,7 +15131,7 @@
         </p:sp>
         <p:sp>
           <p:nvSpPr>
-            <p:cNvPr id="11" name="footer-logo-10"/>
+            <p:cNvPr id="11" name="footer-logo-x reflection band 6"/>
             <p:cNvSpPr/>
             <p:nvPr/>
           </p:nvSpPr>
@@ -15189,7 +15189,7 @@
         </p:sp>
         <p:sp>
           <p:nvSpPr>
-            <p:cNvPr id="12" name="footer-logo-11"/>
+            <p:cNvPr id="12" name="footer-logo-x reflection band 7"/>
             <p:cNvSpPr/>
             <p:nvPr/>
           </p:nvSpPr>
@@ -15247,7 +15247,7 @@
         </p:sp>
         <p:sp>
           <p:nvSpPr>
-            <p:cNvPr id="13" name="footer-logo-12"/>
+            <p:cNvPr id="13" name="footer-logo-l"/>
             <p:cNvSpPr/>
             <p:nvPr/>
           </p:nvSpPr>
@@ -15293,7 +15293,7 @@
         </p:sp>
         <p:sp>
           <p:nvSpPr>
-            <p:cNvPr id="14" name="footer-logo-13"/>
+            <p:cNvPr id="14" name="footer-logo-l reflection band 1"/>
             <p:cNvSpPr/>
             <p:nvPr/>
           </p:nvSpPr>
@@ -15339,7 +15339,7 @@
         </p:sp>
         <p:sp>
           <p:nvSpPr>
-            <p:cNvPr id="15" name="footer-logo-14"/>
+            <p:cNvPr id="15" name="footer-logo-l reflection band 2"/>
             <p:cNvSpPr/>
             <p:nvPr/>
           </p:nvSpPr>
@@ -15385,7 +15385,7 @@
         </p:sp>
         <p:sp>
           <p:nvSpPr>
-            <p:cNvPr id="16" name="footer-logo-15"/>
+            <p:cNvPr id="16" name="footer-logo-l reflection band 3"/>
             <p:cNvSpPr/>
             <p:nvPr/>
           </p:nvSpPr>
@@ -15431,7 +15431,7 @@
         </p:sp>
         <p:sp>
           <p:nvSpPr>
-            <p:cNvPr id="17" name="footer-logo-16"/>
+            <p:cNvPr id="17" name="footer-logo-l reflection band 4"/>
             <p:cNvSpPr/>
             <p:nvPr/>
           </p:nvSpPr>
@@ -15477,7 +15477,7 @@
         </p:sp>
         <p:sp>
           <p:nvSpPr>
-            <p:cNvPr id="18" name="footer-logo-17"/>
+            <p:cNvPr id="18" name="footer-logo-l reflection band 5"/>
             <p:cNvSpPr/>
             <p:nvPr/>
           </p:nvSpPr>
@@ -15523,7 +15523,7 @@
         </p:sp>
         <p:sp>
           <p:nvSpPr>
-            <p:cNvPr id="19" name="footer-logo-18"/>
+            <p:cNvPr id="19" name="footer-logo-l reflection band 6"/>
             <p:cNvSpPr/>
             <p:nvPr/>
           </p:nvSpPr>
@@ -15569,7 +15569,7 @@
         </p:sp>
         <p:sp>
           <p:nvSpPr>
-            <p:cNvPr id="20" name="footer-logo-19"/>
+            <p:cNvPr id="20" name="footer-logo-l reflection band 7"/>
             <p:cNvSpPr/>
             <p:nvPr/>
           </p:nvSpPr>
@@ -16036,7 +16036,7 @@
         </p:grpSpPr>
         <p:sp>
           <p:nvSpPr>
-            <p:cNvPr id="2" name="footer-logo-1"/>
+            <p:cNvPr id="2" name="footer-logo-v"/>
             <p:cNvSpPr/>
             <p:nvPr/>
           </p:nvSpPr>
@@ -16091,7 +16091,7 @@
         </p:sp>
         <p:sp>
           <p:nvSpPr>
-            <p:cNvPr id="3" name="footer-logo-2"/>
+            <p:cNvPr id="3" name="footer-logo-i stem"/>
             <p:cNvSpPr/>
             <p:nvPr/>
           </p:nvSpPr>
@@ -16137,7 +16137,7 @@
         </p:sp>
         <p:sp>
           <p:nvSpPr>
-            <p:cNvPr id="4" name="footer-logo-3"/>
+            <p:cNvPr id="4" name="footer-logo-i dot"/>
             <p:cNvSpPr/>
             <p:nvPr/>
           </p:nvSpPr>
@@ -16183,7 +16183,7 @@
         </p:sp>
         <p:sp>
           <p:nvSpPr>
-            <p:cNvPr id="5" name="footer-logo-4"/>
+            <p:cNvPr id="5" name="footer-logo-x"/>
             <p:cNvSpPr/>
             <p:nvPr/>
           </p:nvSpPr>
@@ -16238,7 +16238,7 @@
         </p:sp>
         <p:sp>
           <p:nvSpPr>
-            <p:cNvPr id="6" name="footer-logo-5"/>
+            <p:cNvPr id="6" name="footer-logo-x reflection band 1"/>
             <p:cNvSpPr/>
             <p:nvPr/>
           </p:nvSpPr>
@@ -16284,7 +16284,7 @@
         </p:sp>
         <p:sp>
           <p:nvSpPr>
-            <p:cNvPr id="7" name="footer-logo-6"/>
+            <p:cNvPr id="7" name="footer-logo-x reflection band 2"/>
             <p:cNvSpPr/>
             <p:nvPr/>
           </p:nvSpPr>
@@ -16330,7 +16330,7 @@
         </p:sp>
         <p:sp>
           <p:nvSpPr>
-            <p:cNvPr id="8" name="footer-logo-7"/>
+            <p:cNvPr id="8" name="footer-logo-x reflection band 3"/>
             <p:cNvSpPr/>
             <p:nvPr/>
           </p:nvSpPr>
@@ -16376,7 +16376,7 @@
         </p:sp>
         <p:sp>
           <p:nvSpPr>
-            <p:cNvPr id="9" name="footer-logo-8"/>
+            <p:cNvPr id="9" name="footer-logo-x reflection band 4"/>
             <p:cNvSpPr/>
             <p:nvPr/>
           </p:nvSpPr>
@@ -16431,7 +16431,7 @@
         </p:sp>
         <p:sp>
           <p:nvSpPr>
-            <p:cNvPr id="10" name="footer-logo-9"/>
+            <p:cNvPr id="10" name="footer-logo-x reflection band 5"/>
             <p:cNvSpPr/>
             <p:nvPr/>
           </p:nvSpPr>
@@ -16489,7 +16489,7 @@
         </p:sp>
         <p:sp>
           <p:nvSpPr>
-            <p:cNvPr id="11" name="footer-logo-10"/>
+            <p:cNvPr id="11" name="footer-logo-x reflection band 6"/>
             <p:cNvSpPr/>
             <p:nvPr/>
           </p:nvSpPr>
@@ -16547,7 +16547,7 @@
         </p:sp>
         <p:sp>
           <p:nvSpPr>
-            <p:cNvPr id="12" name="footer-logo-11"/>
+            <p:cNvPr id="12" name="footer-logo-x reflection band 7"/>
             <p:cNvSpPr/>
             <p:nvPr/>
           </p:nvSpPr>
@@ -16605,7 +16605,7 @@
         </p:sp>
         <p:sp>
           <p:nvSpPr>
-            <p:cNvPr id="13" name="footer-logo-12"/>
+            <p:cNvPr id="13" name="footer-logo-l"/>
             <p:cNvSpPr/>
             <p:nvPr/>
           </p:nvSpPr>
@@ -16651,7 +16651,7 @@
         </p:sp>
         <p:sp>
           <p:nvSpPr>
-            <p:cNvPr id="14" name="footer-logo-13"/>
+            <p:cNvPr id="14" name="footer-logo-l reflection band 1"/>
             <p:cNvSpPr/>
             <p:nvPr/>
           </p:nvSpPr>
@@ -16697,7 +16697,7 @@
         </p:sp>
         <p:sp>
           <p:nvSpPr>
-            <p:cNvPr id="15" name="footer-logo-14"/>
+            <p:cNvPr id="15" name="footer-logo-l reflection band 2"/>
             <p:cNvSpPr/>
             <p:nvPr/>
           </p:nvSpPr>
@@ -16743,7 +16743,7 @@
         </p:sp>
         <p:sp>
           <p:nvSpPr>
-            <p:cNvPr id="16" name="footer-logo-15"/>
+            <p:cNvPr id="16" name="footer-logo-l reflection band 3"/>
             <p:cNvSpPr/>
             <p:nvPr/>
           </p:nvSpPr>
@@ -16789,7 +16789,7 @@
         </p:sp>
         <p:sp>
           <p:nvSpPr>
-            <p:cNvPr id="17" name="footer-logo-16"/>
+            <p:cNvPr id="17" name="footer-logo-l reflection band 4"/>
             <p:cNvSpPr/>
             <p:nvPr/>
           </p:nvSpPr>
@@ -16835,7 +16835,7 @@
         </p:sp>
         <p:sp>
           <p:nvSpPr>
-            <p:cNvPr id="18" name="footer-logo-17"/>
+            <p:cNvPr id="18" name="footer-logo-l reflection band 5"/>
             <p:cNvSpPr/>
             <p:nvPr/>
           </p:nvSpPr>
@@ -16881,7 +16881,7 @@
         </p:sp>
         <p:sp>
           <p:nvSpPr>
-            <p:cNvPr id="19" name="footer-logo-18"/>
+            <p:cNvPr id="19" name="footer-logo-l reflection band 6"/>
             <p:cNvSpPr/>
             <p:nvPr/>
           </p:nvSpPr>
@@ -16927,7 +16927,7 @@
         </p:sp>
         <p:sp>
           <p:nvSpPr>
-            <p:cNvPr id="20" name="footer-logo-19"/>
+            <p:cNvPr id="20" name="footer-logo-l reflection band 7"/>
             <p:cNvSpPr/>
             <p:nvPr/>
           </p:nvSpPr>
@@ -17666,7 +17666,7 @@
         </p:grpSpPr>
         <p:sp>
           <p:nvSpPr>
-            <p:cNvPr id="2" name="footer-logo-1"/>
+            <p:cNvPr id="2" name="footer-logo-v"/>
             <p:cNvSpPr/>
             <p:nvPr/>
           </p:nvSpPr>
@@ -17721,7 +17721,7 @@
         </p:sp>
         <p:sp>
           <p:nvSpPr>
-            <p:cNvPr id="3" name="footer-logo-2"/>
+            <p:cNvPr id="3" name="footer-logo-i stem"/>
             <p:cNvSpPr/>
             <p:nvPr/>
           </p:nvSpPr>
@@ -17767,7 +17767,7 @@
         </p:sp>
         <p:sp>
           <p:nvSpPr>
-            <p:cNvPr id="4" name="footer-logo-3"/>
+            <p:cNvPr id="4" name="footer-logo-i dot"/>
             <p:cNvSpPr/>
             <p:nvPr/>
           </p:nvSpPr>
@@ -17813,7 +17813,7 @@
         </p:sp>
         <p:sp>
           <p:nvSpPr>
-            <p:cNvPr id="5" name="footer-logo-4"/>
+            <p:cNvPr id="5" name="footer-logo-x"/>
             <p:cNvSpPr/>
             <p:nvPr/>
           </p:nvSpPr>
@@ -17868,7 +17868,7 @@
         </p:sp>
         <p:sp>
           <p:nvSpPr>
-            <p:cNvPr id="6" name="footer-logo-5"/>
+            <p:cNvPr id="6" name="footer-logo-x reflection band 1"/>
             <p:cNvSpPr/>
             <p:nvPr/>
           </p:nvSpPr>
@@ -17914,7 +17914,7 @@
         </p:sp>
         <p:sp>
           <p:nvSpPr>
-            <p:cNvPr id="7" name="footer-logo-6"/>
+            <p:cNvPr id="7" name="footer-logo-x reflection band 2"/>
             <p:cNvSpPr/>
             <p:nvPr/>
           </p:nvSpPr>
@@ -17960,7 +17960,7 @@
         </p:sp>
         <p:sp>
           <p:nvSpPr>
-            <p:cNvPr id="8" name="footer-logo-7"/>
+            <p:cNvPr id="8" name="footer-logo-x reflection band 3"/>
             <p:cNvSpPr/>
             <p:nvPr/>
           </p:nvSpPr>
@@ -18006,7 +18006,7 @@
         </p:sp>
         <p:sp>
           <p:nvSpPr>
-            <p:cNvPr id="9" name="footer-logo-8"/>
+            <p:cNvPr id="9" name="footer-logo-x reflection band 4"/>
             <p:cNvSpPr/>
             <p:nvPr/>
           </p:nvSpPr>
@@ -18061,7 +18061,7 @@
         </p:sp>
         <p:sp>
           <p:nvSpPr>
-            <p:cNvPr id="10" name="footer-logo-9"/>
+            <p:cNvPr id="10" name="footer-logo-x reflection band 5"/>
             <p:cNvSpPr/>
             <p:nvPr/>
           </p:nvSpPr>
@@ -18119,7 +18119,7 @@
         </p:sp>
         <p:sp>
           <p:nvSpPr>
-            <p:cNvPr id="11" name="footer-logo-10"/>
+            <p:cNvPr id="11" name="footer-logo-x reflection band 6"/>
             <p:cNvSpPr/>
             <p:nvPr/>
           </p:nvSpPr>
@@ -18177,7 +18177,7 @@
         </p:sp>
         <p:sp>
           <p:nvSpPr>
-            <p:cNvPr id="12" name="footer-logo-11"/>
+            <p:cNvPr id="12" name="footer-logo-x reflection band 7"/>
             <p:cNvSpPr/>
             <p:nvPr/>
           </p:nvSpPr>
@@ -18235,7 +18235,7 @@
         </p:sp>
         <p:sp>
           <p:nvSpPr>
-            <p:cNvPr id="13" name="footer-logo-12"/>
+            <p:cNvPr id="13" name="footer-logo-l"/>
             <p:cNvSpPr/>
             <p:nvPr/>
           </p:nvSpPr>
@@ -18281,7 +18281,7 @@
         </p:sp>
         <p:sp>
           <p:nvSpPr>
-            <p:cNvPr id="14" name="footer-logo-13"/>
+            <p:cNvPr id="14" name="footer-logo-l reflection band 1"/>
             <p:cNvSpPr/>
             <p:nvPr/>
           </p:nvSpPr>
@@ -18327,7 +18327,7 @@
         </p:sp>
         <p:sp>
           <p:nvSpPr>
-            <p:cNvPr id="15" name="footer-logo-14"/>
+            <p:cNvPr id="15" name="footer-logo-l reflection band 2"/>
             <p:cNvSpPr/>
             <p:nvPr/>
           </p:nvSpPr>
@@ -18373,7 +18373,7 @@
         </p:sp>
         <p:sp>
           <p:nvSpPr>
-            <p:cNvPr id="16" name="footer-logo-15"/>
+            <p:cNvPr id="16" name="footer-logo-l reflection band 3"/>
             <p:cNvSpPr/>
             <p:nvPr/>
           </p:nvSpPr>
@@ -18419,7 +18419,7 @@
         </p:sp>
         <p:sp>
           <p:nvSpPr>
-            <p:cNvPr id="17" name="footer-logo-16"/>
+            <p:cNvPr id="17" name="footer-logo-l reflection band 4"/>
             <p:cNvSpPr/>
             <p:nvPr/>
           </p:nvSpPr>
@@ -18465,7 +18465,7 @@
         </p:sp>
         <p:sp>
           <p:nvSpPr>
-            <p:cNvPr id="18" name="footer-logo-17"/>
+            <p:cNvPr id="18" name="footer-logo-l reflection band 5"/>
             <p:cNvSpPr/>
             <p:nvPr/>
           </p:nvSpPr>
@@ -18511,7 +18511,7 @@
         </p:sp>
         <p:sp>
           <p:nvSpPr>
-            <p:cNvPr id="19" name="footer-logo-18"/>
+            <p:cNvPr id="19" name="footer-logo-l reflection band 6"/>
             <p:cNvSpPr/>
             <p:nvPr/>
           </p:nvSpPr>
@@ -18557,7 +18557,7 @@
         </p:sp>
         <p:sp>
           <p:nvSpPr>
-            <p:cNvPr id="20" name="footer-logo-19"/>
+            <p:cNvPr id="20" name="footer-logo-l reflection band 7"/>
             <p:cNvSpPr/>
             <p:nvPr/>
           </p:nvSpPr>
@@ -19281,7 +19281,7 @@
         </p:grpSpPr>
         <p:sp>
           <p:nvSpPr>
-            <p:cNvPr id="2" name="footer-logo-1"/>
+            <p:cNvPr id="2" name="footer-logo-v"/>
             <p:cNvSpPr/>
             <p:nvPr/>
           </p:nvSpPr>
@@ -19336,7 +19336,7 @@
         </p:sp>
         <p:sp>
           <p:nvSpPr>
-            <p:cNvPr id="3" name="footer-logo-2"/>
+            <p:cNvPr id="3" name="footer-logo-i stem"/>
             <p:cNvSpPr/>
             <p:nvPr/>
           </p:nvSpPr>
@@ -19382,7 +19382,7 @@
         </p:sp>
         <p:sp>
           <p:nvSpPr>
-            <p:cNvPr id="4" name="footer-logo-3"/>
+            <p:cNvPr id="4" name="footer-logo-i dot"/>
             <p:cNvSpPr/>
             <p:nvPr/>
           </p:nvSpPr>
@@ -19428,7 +19428,7 @@
         </p:sp>
         <p:sp>
           <p:nvSpPr>
-            <p:cNvPr id="5" name="footer-logo-4"/>
+            <p:cNvPr id="5" name="footer-logo-x"/>
             <p:cNvSpPr/>
             <p:nvPr/>
           </p:nvSpPr>
@@ -19483,7 +19483,7 @@
         </p:sp>
         <p:sp>
           <p:nvSpPr>
-            <p:cNvPr id="6" name="footer-logo-5"/>
+            <p:cNvPr id="6" name="footer-logo-x reflection band 1"/>
             <p:cNvSpPr/>
             <p:nvPr/>
           </p:nvSpPr>
@@ -19529,7 +19529,7 @@
         </p:sp>
         <p:sp>
           <p:nvSpPr>
-            <p:cNvPr id="7" name="footer-logo-6"/>
+            <p:cNvPr id="7" name="footer-logo-x reflection band 2"/>
             <p:cNvSpPr/>
             <p:nvPr/>
           </p:nvSpPr>
@@ -19575,7 +19575,7 @@
         </p:sp>
         <p:sp>
           <p:nvSpPr>
-            <p:cNvPr id="8" name="footer-logo-7"/>
+            <p:cNvPr id="8" name="footer-logo-x reflection band 3"/>
             <p:cNvSpPr/>
             <p:nvPr/>
           </p:nvSpPr>
@@ -19621,7 +19621,7 @@
         </p:sp>
         <p:sp>
           <p:nvSpPr>
-            <p:cNvPr id="9" name="footer-logo-8"/>
+            <p:cNvPr id="9" name="footer-logo-x reflection band 4"/>
             <p:cNvSpPr/>
             <p:nvPr/>
           </p:nvSpPr>
@@ -19676,7 +19676,7 @@
         </p:sp>
         <p:sp>
           <p:nvSpPr>
-            <p:cNvPr id="10" name="footer-logo-9"/>
+            <p:cNvPr id="10" name="footer-logo-x reflection band 5"/>
             <p:cNvSpPr/>
             <p:nvPr/>
           </p:nvSpPr>
@@ -19734,7 +19734,7 @@
         </p:sp>
         <p:sp>
           <p:nvSpPr>
-            <p:cNvPr id="11" name="footer-logo-10"/>
+            <p:cNvPr id="11" name="footer-logo-x reflection band 6"/>
             <p:cNvSpPr/>
             <p:nvPr/>
           </p:nvSpPr>
@@ -19792,7 +19792,7 @@
         </p:sp>
         <p:sp>
           <p:nvSpPr>
-            <p:cNvPr id="12" name="footer-logo-11"/>
+            <p:cNvPr id="12" name="footer-logo-x reflection band 7"/>
             <p:cNvSpPr/>
             <p:nvPr/>
           </p:nvSpPr>
@@ -19850,7 +19850,7 @@
         </p:sp>
         <p:sp>
           <p:nvSpPr>
-            <p:cNvPr id="13" name="footer-logo-12"/>
+            <p:cNvPr id="13" name="footer-logo-l"/>
             <p:cNvSpPr/>
             <p:nvPr/>
           </p:nvSpPr>
@@ -19896,7 +19896,7 @@
         </p:sp>
         <p:sp>
           <p:nvSpPr>
-            <p:cNvPr id="14" name="footer-logo-13"/>
+            <p:cNvPr id="14" name="footer-logo-l reflection band 1"/>
             <p:cNvSpPr/>
             <p:nvPr/>
           </p:nvSpPr>
@@ -19942,7 +19942,7 @@
         </p:sp>
         <p:sp>
           <p:nvSpPr>
-            <p:cNvPr id="15" name="footer-logo-14"/>
+            <p:cNvPr id="15" name="footer-logo-l reflection band 2"/>
             <p:cNvSpPr/>
             <p:nvPr/>
           </p:nvSpPr>
@@ -19988,7 +19988,7 @@
         </p:sp>
         <p:sp>
           <p:nvSpPr>
-            <p:cNvPr id="16" name="footer-logo-15"/>
+            <p:cNvPr id="16" name="footer-logo-l reflection band 3"/>
             <p:cNvSpPr/>
             <p:nvPr/>
           </p:nvSpPr>
@@ -20034,7 +20034,7 @@
         </p:sp>
         <p:sp>
           <p:nvSpPr>
-            <p:cNvPr id="17" name="footer-logo-16"/>
+            <p:cNvPr id="17" name="footer-logo-l reflection band 4"/>
             <p:cNvSpPr/>
             <p:nvPr/>
           </p:nvSpPr>
@@ -20080,7 +20080,7 @@
         </p:sp>
         <p:sp>
           <p:nvSpPr>
-            <p:cNvPr id="18" name="footer-logo-17"/>
+            <p:cNvPr id="18" name="footer-logo-l reflection band 5"/>
             <p:cNvSpPr/>
             <p:nvPr/>
           </p:nvSpPr>
@@ -20126,7 +20126,7 @@
         </p:sp>
         <p:sp>
           <p:nvSpPr>
-            <p:cNvPr id="19" name="footer-logo-18"/>
+            <p:cNvPr id="19" name="footer-logo-l reflection band 6"/>
             <p:cNvSpPr/>
             <p:nvPr/>
           </p:nvSpPr>
@@ -20172,7 +20172,7 @@
         </p:sp>
         <p:sp>
           <p:nvSpPr>
-            <p:cNvPr id="20" name="footer-logo-19"/>
+            <p:cNvPr id="20" name="footer-logo-l reflection band 7"/>
             <p:cNvSpPr/>
             <p:nvPr/>
           </p:nvSpPr>

</xml_diff>